<commit_message>
updated slides, added edit to milestones
</commit_message>
<xml_diff>
--- a/design_presentation.pptx
+++ b/design_presentation.pptx
@@ -5,7 +5,7 @@
     <p:sldMasterId id="2147483648" r:id="rId1"/>
   </p:sldMasterIdLst>
   <p:notesMasterIdLst>
-    <p:notesMasterId r:id="rId12"/>
+    <p:notesMasterId r:id="rId16"/>
   </p:notesMasterIdLst>
   <p:sldIdLst>
     <p:sldId id="256" r:id="rId2"/>
@@ -17,7 +17,11 @@
     <p:sldId id="265" r:id="rId8"/>
     <p:sldId id="260" r:id="rId9"/>
     <p:sldId id="266" r:id="rId10"/>
-    <p:sldId id="263" r:id="rId11"/>
+    <p:sldId id="269" r:id="rId11"/>
+    <p:sldId id="268" r:id="rId12"/>
+    <p:sldId id="270" r:id="rId13"/>
+    <p:sldId id="267" r:id="rId14"/>
+    <p:sldId id="263" r:id="rId15"/>
   </p:sldIdLst>
   <p:sldSz cx="12192000" cy="6858000"/>
   <p:notesSz cx="6858000" cy="9144000"/>
@@ -206,7 +210,7 @@
           <a:p>
             <a:fld id="{D7F559F5-2DAC-4629-9D6E-D700034D2FAB}" type="datetimeFigureOut">
               <a:rPr lang="en-001" smtClean="0"/>
-              <a:t>03/02/2026</a:t>
+              <a:t>04/02/2026</a:t>
             </a:fld>
             <a:endParaRPr lang="en-001"/>
           </a:p>
@@ -574,6 +578,198 @@
 </p:notes>
 </file>
 
+<file path=ppt/notesSlides/notesSlide10.xml><?xml version="1.0" encoding="utf-8"?>
+<p:notes xmlns:a="http://schemas.openxmlformats.org/drawingml/2006/main" xmlns:r="http://schemas.openxmlformats.org/officeDocument/2006/relationships" xmlns:p="http://schemas.openxmlformats.org/presentationml/2006/main">
+  <p:cSld>
+    <p:spTree>
+      <p:nvGrpSpPr>
+        <p:cNvPr id="1" name=""/>
+        <p:cNvGrpSpPr/>
+        <p:nvPr/>
+      </p:nvGrpSpPr>
+      <p:grpSpPr>
+        <a:xfrm>
+          <a:off x="0" y="0"/>
+          <a:ext cx="0" cy="0"/>
+          <a:chOff x="0" y="0"/>
+          <a:chExt cx="0" cy="0"/>
+        </a:xfrm>
+      </p:grpSpPr>
+      <p:sp>
+        <p:nvSpPr>
+          <p:cNvPr id="2" name="Slide Image Placeholder 1"/>
+          <p:cNvSpPr>
+            <a:spLocks noGrp="1" noRot="1" noChangeAspect="1"/>
+          </p:cNvSpPr>
+          <p:nvPr>
+            <p:ph type="sldImg"/>
+          </p:nvPr>
+        </p:nvSpPr>
+        <p:spPr/>
+      </p:sp>
+      <p:sp>
+        <p:nvSpPr>
+          <p:cNvPr id="3" name="Notes Placeholder 2"/>
+          <p:cNvSpPr>
+            <a:spLocks noGrp="1"/>
+          </p:cNvSpPr>
+          <p:nvPr>
+            <p:ph type="body" idx="1"/>
+          </p:nvPr>
+        </p:nvSpPr>
+        <p:spPr/>
+        <p:txBody>
+          <a:bodyPr/>
+          <a:lstStyle/>
+          <a:p>
+            <a:endParaRPr lang="en-US" dirty="0"/>
+          </a:p>
+        </p:txBody>
+      </p:sp>
+      <p:sp>
+        <p:nvSpPr>
+          <p:cNvPr id="4" name="Slide Number Placeholder 3"/>
+          <p:cNvSpPr>
+            <a:spLocks noGrp="1"/>
+          </p:cNvSpPr>
+          <p:nvPr>
+            <p:ph type="sldNum" sz="quarter" idx="5"/>
+          </p:nvPr>
+        </p:nvSpPr>
+        <p:spPr/>
+        <p:txBody>
+          <a:bodyPr/>
+          <a:lstStyle/>
+          <a:p>
+            <a:fld id="{AA35E14C-0906-485E-9492-8D1923B67659}" type="slidenum">
+              <a:rPr lang="en-001" smtClean="0"/>
+              <a:t>13</a:t>
+            </a:fld>
+            <a:endParaRPr lang="en-001"/>
+          </a:p>
+        </p:txBody>
+      </p:sp>
+    </p:spTree>
+    <p:extLst>
+      <p:ext uri="{BB962C8B-B14F-4D97-AF65-F5344CB8AC3E}">
+        <p14:creationId xmlns:p14="http://schemas.microsoft.com/office/powerpoint/2010/main" val="36784036"/>
+      </p:ext>
+    </p:extLst>
+  </p:cSld>
+  <p:clrMapOvr>
+    <a:masterClrMapping/>
+  </p:clrMapOvr>
+</p:notes>
+</file>
+
+<file path=ppt/notesSlides/notesSlide11.xml><?xml version="1.0" encoding="utf-8"?>
+<p:notes xmlns:a="http://schemas.openxmlformats.org/drawingml/2006/main" xmlns:r="http://schemas.openxmlformats.org/officeDocument/2006/relationships" xmlns:p="http://schemas.openxmlformats.org/presentationml/2006/main">
+  <p:cSld>
+    <p:spTree>
+      <p:nvGrpSpPr>
+        <p:cNvPr id="1" name=""/>
+        <p:cNvGrpSpPr/>
+        <p:nvPr/>
+      </p:nvGrpSpPr>
+      <p:grpSpPr>
+        <a:xfrm>
+          <a:off x="0" y="0"/>
+          <a:ext cx="0" cy="0"/>
+          <a:chOff x="0" y="0"/>
+          <a:chExt cx="0" cy="0"/>
+        </a:xfrm>
+      </p:grpSpPr>
+      <p:sp>
+        <p:nvSpPr>
+          <p:cNvPr id="2" name="Slide Image Placeholder 1"/>
+          <p:cNvSpPr>
+            <a:spLocks noGrp="1" noRot="1" noChangeAspect="1"/>
+          </p:cNvSpPr>
+          <p:nvPr>
+            <p:ph type="sldImg"/>
+          </p:nvPr>
+        </p:nvSpPr>
+        <p:spPr/>
+      </p:sp>
+      <p:sp>
+        <p:nvSpPr>
+          <p:cNvPr id="3" name="Notes Placeholder 2"/>
+          <p:cNvSpPr>
+            <a:spLocks noGrp="1"/>
+          </p:cNvSpPr>
+          <p:nvPr>
+            <p:ph type="body" idx="1"/>
+          </p:nvPr>
+        </p:nvSpPr>
+        <p:spPr/>
+        <p:txBody>
+          <a:bodyPr/>
+          <a:lstStyle/>
+          <a:p>
+            <a:r>
+              <a:rPr lang="en-US" dirty="0"/>
+              <a:t>Yellow highlight is everything not necessarily needed for MVP.</a:t>
+            </a:r>
+          </a:p>
+          <a:p>
+            <a:r>
+              <a:rPr lang="en-US" dirty="0"/>
+              <a:t>7 / 18 milestones are done; Another is mostly done.</a:t>
+            </a:r>
+          </a:p>
+          <a:p>
+            <a:r>
+              <a:rPr lang="en-US" dirty="0"/>
+              <a:t>Most of remaining work will be the game itself and then debugging the integration of the application.</a:t>
+            </a:r>
+          </a:p>
+          <a:p>
+            <a:r>
+              <a:rPr lang="en-US" dirty="0"/>
+              <a:t>All the web-based stuff is completed.</a:t>
+            </a:r>
+          </a:p>
+          <a:p>
+            <a:endParaRPr lang="en-001" dirty="0"/>
+          </a:p>
+        </p:txBody>
+      </p:sp>
+      <p:sp>
+        <p:nvSpPr>
+          <p:cNvPr id="4" name="Slide Number Placeholder 3"/>
+          <p:cNvSpPr>
+            <a:spLocks noGrp="1"/>
+          </p:cNvSpPr>
+          <p:nvPr>
+            <p:ph type="sldNum" sz="quarter" idx="5"/>
+          </p:nvPr>
+        </p:nvSpPr>
+        <p:spPr/>
+        <p:txBody>
+          <a:bodyPr/>
+          <a:lstStyle/>
+          <a:p>
+            <a:fld id="{AA35E14C-0906-485E-9492-8D1923B67659}" type="slidenum">
+              <a:rPr lang="en-001" smtClean="0"/>
+              <a:t>14</a:t>
+            </a:fld>
+            <a:endParaRPr lang="en-001"/>
+          </a:p>
+        </p:txBody>
+      </p:sp>
+    </p:spTree>
+    <p:extLst>
+      <p:ext uri="{BB962C8B-B14F-4D97-AF65-F5344CB8AC3E}">
+        <p14:creationId xmlns:p14="http://schemas.microsoft.com/office/powerpoint/2010/main" val="1234605880"/>
+      </p:ext>
+    </p:extLst>
+  </p:cSld>
+  <p:clrMapOvr>
+    <a:masterClrMapping/>
+  </p:clrMapOvr>
+</p:notes>
+</file>
+
 <file path=ppt/notesSlides/notesSlide2.xml><?xml version="1.0" encoding="utf-8"?>
 <p:notes xmlns:a="http://schemas.openxmlformats.org/drawingml/2006/main" xmlns:r="http://schemas.openxmlformats.org/officeDocument/2006/relationships" xmlns:p="http://schemas.openxmlformats.org/presentationml/2006/main">
   <p:cSld>
@@ -619,8 +815,12 @@
           <a:lstStyle/>
           <a:p>
             <a:r>
-              <a:rPr lang="en-US" dirty="0"/>
-              <a:t>Started late so I am the sole contributor </a:t>
+              <a:rPr lang="en-US" dirty="0" err="1"/>
+              <a:t>TrustedSec</a:t>
+            </a:r>
+            <a:r>
+              <a:rPr lang="en-US" dirty="0"/>
+              <a:t> – Security Consultant</a:t>
             </a:r>
             <a:endParaRPr lang="en-001" dirty="0"/>
           </a:p>
@@ -712,7 +912,7 @@
             </a:pPr>
             <a:r>
               <a:rPr lang="en-US" dirty="0"/>
-              <a:t>Similarities with fall guys</a:t>
+              <a:t>Goal was to make an LLM powered game</a:t>
             </a:r>
           </a:p>
           <a:p>
@@ -721,12 +921,24 @@
               <a:buChar char="•"/>
             </a:pPr>
             <a:r>
+              <a:rPr lang="en-US" dirty="0"/>
+              <a:t>Most existing games are </a:t>
+            </a:r>
+            <a:r>
               <a:rPr lang="en-US" dirty="0" err="1"/>
-              <a:t>Brainrot</a:t>
-            </a:r>
-            <a:r>
-              <a:rPr lang="en-US" dirty="0"/>
-              <a:t> games</a:t>
+              <a:t>brainrot</a:t>
+            </a:r>
+            <a:r>
+              <a:rPr lang="en-US" dirty="0"/>
+              <a:t> (subway surfer, temple run </a:t>
+            </a:r>
+            <a:r>
+              <a:rPr lang="en-US" dirty="0" err="1"/>
+              <a:t>ect</a:t>
+            </a:r>
+            <a:r>
+              <a:rPr lang="en-US" dirty="0"/>
+              <a:t>.) and usually paid.</a:t>
             </a:r>
           </a:p>
           <a:p>
@@ -736,9 +948,8 @@
             </a:pPr>
             <a:r>
               <a:rPr lang="en-US" dirty="0"/>
-              <a:t>Paid features</a:t>
-            </a:r>
-            <a:endParaRPr lang="en-001" dirty="0"/>
+              <a:t>Decided multiplayer was the best way to make it fun because fun game mechanics are difficult and competition is inherently fun.</a:t>
+            </a:r>
           </a:p>
         </p:txBody>
       </p:sp>
@@ -1141,6 +1352,182 @@
     <p:extLst>
       <p:ext uri="{BB962C8B-B14F-4D97-AF65-F5344CB8AC3E}">
         <p14:creationId xmlns:p14="http://schemas.microsoft.com/office/powerpoint/2010/main" val="2175107589"/>
+      </p:ext>
+    </p:extLst>
+  </p:cSld>
+  <p:clrMapOvr>
+    <a:masterClrMapping/>
+  </p:clrMapOvr>
+</p:notes>
+</file>
+
+<file path=ppt/notesSlides/notesSlide8.xml><?xml version="1.0" encoding="utf-8"?>
+<p:notes xmlns:a="http://schemas.openxmlformats.org/drawingml/2006/main" xmlns:r="http://schemas.openxmlformats.org/officeDocument/2006/relationships" xmlns:p="http://schemas.openxmlformats.org/presentationml/2006/main">
+  <p:cSld>
+    <p:spTree>
+      <p:nvGrpSpPr>
+        <p:cNvPr id="1" name=""/>
+        <p:cNvGrpSpPr/>
+        <p:nvPr/>
+      </p:nvGrpSpPr>
+      <p:grpSpPr>
+        <a:xfrm>
+          <a:off x="0" y="0"/>
+          <a:ext cx="0" cy="0"/>
+          <a:chOff x="0" y="0"/>
+          <a:chExt cx="0" cy="0"/>
+        </a:xfrm>
+      </p:grpSpPr>
+      <p:sp>
+        <p:nvSpPr>
+          <p:cNvPr id="2" name="Slide Image Placeholder 1"/>
+          <p:cNvSpPr>
+            <a:spLocks noGrp="1" noRot="1" noChangeAspect="1"/>
+          </p:cNvSpPr>
+          <p:nvPr>
+            <p:ph type="sldImg"/>
+          </p:nvPr>
+        </p:nvSpPr>
+        <p:spPr/>
+      </p:sp>
+      <p:sp>
+        <p:nvSpPr>
+          <p:cNvPr id="3" name="Notes Placeholder 2"/>
+          <p:cNvSpPr>
+            <a:spLocks noGrp="1"/>
+          </p:cNvSpPr>
+          <p:nvPr>
+            <p:ph type="body" idx="1"/>
+          </p:nvPr>
+        </p:nvSpPr>
+        <p:spPr/>
+        <p:txBody>
+          <a:bodyPr/>
+          <a:lstStyle/>
+          <a:p>
+            <a:r>
+              <a:rPr lang="en-US" dirty="0"/>
+              <a:t>Future: preventative auth rules</a:t>
+            </a:r>
+            <a:endParaRPr lang="en-001" dirty="0"/>
+          </a:p>
+        </p:txBody>
+      </p:sp>
+      <p:sp>
+        <p:nvSpPr>
+          <p:cNvPr id="4" name="Slide Number Placeholder 3"/>
+          <p:cNvSpPr>
+            <a:spLocks noGrp="1"/>
+          </p:cNvSpPr>
+          <p:nvPr>
+            <p:ph type="sldNum" sz="quarter" idx="5"/>
+          </p:nvPr>
+        </p:nvSpPr>
+        <p:spPr/>
+        <p:txBody>
+          <a:bodyPr/>
+          <a:lstStyle/>
+          <a:p>
+            <a:fld id="{AA35E14C-0906-485E-9492-8D1923B67659}" type="slidenum">
+              <a:rPr lang="en-001" smtClean="0"/>
+              <a:t>10</a:t>
+            </a:fld>
+            <a:endParaRPr lang="en-001"/>
+          </a:p>
+        </p:txBody>
+      </p:sp>
+    </p:spTree>
+    <p:extLst>
+      <p:ext uri="{BB962C8B-B14F-4D97-AF65-F5344CB8AC3E}">
+        <p14:creationId xmlns:p14="http://schemas.microsoft.com/office/powerpoint/2010/main" val="335586268"/>
+      </p:ext>
+    </p:extLst>
+  </p:cSld>
+  <p:clrMapOvr>
+    <a:masterClrMapping/>
+  </p:clrMapOvr>
+</p:notes>
+</file>
+
+<file path=ppt/notesSlides/notesSlide9.xml><?xml version="1.0" encoding="utf-8"?>
+<p:notes xmlns:a="http://schemas.openxmlformats.org/drawingml/2006/main" xmlns:r="http://schemas.openxmlformats.org/officeDocument/2006/relationships" xmlns:p="http://schemas.openxmlformats.org/presentationml/2006/main">
+  <p:cSld>
+    <p:spTree>
+      <p:nvGrpSpPr>
+        <p:cNvPr id="1" name=""/>
+        <p:cNvGrpSpPr/>
+        <p:nvPr/>
+      </p:nvGrpSpPr>
+      <p:grpSpPr>
+        <a:xfrm>
+          <a:off x="0" y="0"/>
+          <a:ext cx="0" cy="0"/>
+          <a:chOff x="0" y="0"/>
+          <a:chExt cx="0" cy="0"/>
+        </a:xfrm>
+      </p:grpSpPr>
+      <p:sp>
+        <p:nvSpPr>
+          <p:cNvPr id="2" name="Slide Image Placeholder 1"/>
+          <p:cNvSpPr>
+            <a:spLocks noGrp="1" noRot="1" noChangeAspect="1"/>
+          </p:cNvSpPr>
+          <p:nvPr>
+            <p:ph type="sldImg"/>
+          </p:nvPr>
+        </p:nvSpPr>
+        <p:spPr/>
+      </p:sp>
+      <p:sp>
+        <p:nvSpPr>
+          <p:cNvPr id="3" name="Notes Placeholder 2"/>
+          <p:cNvSpPr>
+            <a:spLocks noGrp="1"/>
+          </p:cNvSpPr>
+          <p:nvPr>
+            <p:ph type="body" idx="1"/>
+          </p:nvPr>
+        </p:nvSpPr>
+        <p:spPr/>
+        <p:txBody>
+          <a:bodyPr/>
+          <a:lstStyle/>
+          <a:p>
+            <a:r>
+              <a:rPr lang="en-US" dirty="0"/>
+              <a:t>Still need to add button for LLM generation</a:t>
+            </a:r>
+            <a:endParaRPr lang="en-001" dirty="0"/>
+          </a:p>
+        </p:txBody>
+      </p:sp>
+      <p:sp>
+        <p:nvSpPr>
+          <p:cNvPr id="4" name="Slide Number Placeholder 3"/>
+          <p:cNvSpPr>
+            <a:spLocks noGrp="1"/>
+          </p:cNvSpPr>
+          <p:nvPr>
+            <p:ph type="sldNum" sz="quarter" idx="5"/>
+          </p:nvPr>
+        </p:nvSpPr>
+        <p:spPr/>
+        <p:txBody>
+          <a:bodyPr/>
+          <a:lstStyle/>
+          <a:p>
+            <a:fld id="{AA35E14C-0906-485E-9492-8D1923B67659}" type="slidenum">
+              <a:rPr lang="en-001" smtClean="0"/>
+              <a:t>11</a:t>
+            </a:fld>
+            <a:endParaRPr lang="en-001"/>
+          </a:p>
+        </p:txBody>
+      </p:sp>
+    </p:spTree>
+    <p:extLst>
+      <p:ext uri="{BB962C8B-B14F-4D97-AF65-F5344CB8AC3E}">
+        <p14:creationId xmlns:p14="http://schemas.microsoft.com/office/powerpoint/2010/main" val="2368930098"/>
       </p:ext>
     </p:extLst>
   </p:cSld>
@@ -1299,7 +1686,7 @@
           <a:p>
             <a:fld id="{9245BF56-8465-4FFB-B48D-453AF47B0D77}" type="datetimeFigureOut">
               <a:rPr lang="en-001" smtClean="0"/>
-              <a:t>03/02/2026</a:t>
+              <a:t>04/02/2026</a:t>
             </a:fld>
             <a:endParaRPr lang="en-001"/>
           </a:p>
@@ -1499,7 +1886,7 @@
           <a:p>
             <a:fld id="{9245BF56-8465-4FFB-B48D-453AF47B0D77}" type="datetimeFigureOut">
               <a:rPr lang="en-001" smtClean="0"/>
-              <a:t>03/02/2026</a:t>
+              <a:t>04/02/2026</a:t>
             </a:fld>
             <a:endParaRPr lang="en-001"/>
           </a:p>
@@ -1709,7 +2096,7 @@
           <a:p>
             <a:fld id="{9245BF56-8465-4FFB-B48D-453AF47B0D77}" type="datetimeFigureOut">
               <a:rPr lang="en-001" smtClean="0"/>
-              <a:t>03/02/2026</a:t>
+              <a:t>04/02/2026</a:t>
             </a:fld>
             <a:endParaRPr lang="en-001"/>
           </a:p>
@@ -1909,7 +2296,7 @@
           <a:p>
             <a:fld id="{9245BF56-8465-4FFB-B48D-453AF47B0D77}" type="datetimeFigureOut">
               <a:rPr lang="en-001" smtClean="0"/>
-              <a:t>03/02/2026</a:t>
+              <a:t>04/02/2026</a:t>
             </a:fld>
             <a:endParaRPr lang="en-001"/>
           </a:p>
@@ -2185,7 +2572,7 @@
           <a:p>
             <a:fld id="{9245BF56-8465-4FFB-B48D-453AF47B0D77}" type="datetimeFigureOut">
               <a:rPr lang="en-001" smtClean="0"/>
-              <a:t>03/02/2026</a:t>
+              <a:t>04/02/2026</a:t>
             </a:fld>
             <a:endParaRPr lang="en-001"/>
           </a:p>
@@ -2453,7 +2840,7 @@
           <a:p>
             <a:fld id="{9245BF56-8465-4FFB-B48D-453AF47B0D77}" type="datetimeFigureOut">
               <a:rPr lang="en-001" smtClean="0"/>
-              <a:t>03/02/2026</a:t>
+              <a:t>04/02/2026</a:t>
             </a:fld>
             <a:endParaRPr lang="en-001"/>
           </a:p>
@@ -2868,7 +3255,7 @@
           <a:p>
             <a:fld id="{9245BF56-8465-4FFB-B48D-453AF47B0D77}" type="datetimeFigureOut">
               <a:rPr lang="en-001" smtClean="0"/>
-              <a:t>03/02/2026</a:t>
+              <a:t>04/02/2026</a:t>
             </a:fld>
             <a:endParaRPr lang="en-001"/>
           </a:p>
@@ -3010,7 +3397,7 @@
           <a:p>
             <a:fld id="{9245BF56-8465-4FFB-B48D-453AF47B0D77}" type="datetimeFigureOut">
               <a:rPr lang="en-001" smtClean="0"/>
-              <a:t>03/02/2026</a:t>
+              <a:t>04/02/2026</a:t>
             </a:fld>
             <a:endParaRPr lang="en-001"/>
           </a:p>
@@ -3123,7 +3510,7 @@
           <a:p>
             <a:fld id="{9245BF56-8465-4FFB-B48D-453AF47B0D77}" type="datetimeFigureOut">
               <a:rPr lang="en-001" smtClean="0"/>
-              <a:t>03/02/2026</a:t>
+              <a:t>04/02/2026</a:t>
             </a:fld>
             <a:endParaRPr lang="en-001"/>
           </a:p>
@@ -3436,7 +3823,7 @@
           <a:p>
             <a:fld id="{9245BF56-8465-4FFB-B48D-453AF47B0D77}" type="datetimeFigureOut">
               <a:rPr lang="en-001" smtClean="0"/>
-              <a:t>03/02/2026</a:t>
+              <a:t>04/02/2026</a:t>
             </a:fld>
             <a:endParaRPr lang="en-001"/>
           </a:p>
@@ -3725,7 +4112,7 @@
           <a:p>
             <a:fld id="{9245BF56-8465-4FFB-B48D-453AF47B0D77}" type="datetimeFigureOut">
               <a:rPr lang="en-001" smtClean="0"/>
-              <a:t>03/02/2026</a:t>
+              <a:t>04/02/2026</a:t>
             </a:fld>
             <a:endParaRPr lang="en-001"/>
           </a:p>
@@ -3968,7 +4355,7 @@
           <a:p>
             <a:fld id="{9245BF56-8465-4FFB-B48D-453AF47B0D77}" type="datetimeFigureOut">
               <a:rPr lang="en-001" smtClean="0"/>
-              <a:t>03/02/2026</a:t>
+              <a:t>04/02/2026</a:t>
             </a:fld>
             <a:endParaRPr lang="en-001"/>
           </a:p>
@@ -4478,6 +4865,656 @@
           <p:cNvPr id="2" name="Title 1">
             <a:extLst>
               <a:ext uri="{FF2B5EF4-FFF2-40B4-BE49-F238E27FC236}">
+                <a16:creationId xmlns:a16="http://schemas.microsoft.com/office/drawing/2014/main" id="{3F81C4E8-06CD-4682-87E2-4A62F578FFCF}"/>
+              </a:ext>
+            </a:extLst>
+          </p:cNvPr>
+          <p:cNvSpPr>
+            <a:spLocks noGrp="1"/>
+          </p:cNvSpPr>
+          <p:nvPr>
+            <p:ph type="title"/>
+          </p:nvPr>
+        </p:nvSpPr>
+        <p:spPr/>
+        <p:txBody>
+          <a:bodyPr/>
+          <a:lstStyle/>
+          <a:p>
+            <a:endParaRPr lang="en-001"/>
+          </a:p>
+        </p:txBody>
+      </p:sp>
+      <p:pic>
+        <p:nvPicPr>
+          <p:cNvPr id="5" name="Content Placeholder 4">
+            <a:extLst>
+              <a:ext uri="{FF2B5EF4-FFF2-40B4-BE49-F238E27FC236}">
+                <a16:creationId xmlns:a16="http://schemas.microsoft.com/office/drawing/2014/main" id="{CDD77C09-A741-A9A2-C5E1-76C18A81B4C3}"/>
+              </a:ext>
+            </a:extLst>
+          </p:cNvPr>
+          <p:cNvPicPr>
+            <a:picLocks noGrp="1" noChangeAspect="1"/>
+          </p:cNvPicPr>
+          <p:nvPr>
+            <p:ph idx="1"/>
+          </p:nvPr>
+        </p:nvPicPr>
+        <p:blipFill>
+          <a:blip r:embed="rId3">
+            <a:extLst>
+              <a:ext uri="{28A0092B-C50C-407E-A947-70E740481C1C}">
+                <a14:useLocalDpi xmlns:a14="http://schemas.microsoft.com/office/drawing/2010/main" val="0"/>
+              </a:ext>
+            </a:extLst>
+          </a:blip>
+          <a:stretch>
+            <a:fillRect/>
+          </a:stretch>
+        </p:blipFill>
+        <p:spPr>
+          <a:xfrm>
+            <a:off x="-1" y="0"/>
+            <a:ext cx="12201895" cy="6858000"/>
+          </a:xfrm>
+        </p:spPr>
+      </p:pic>
+    </p:spTree>
+    <p:extLst>
+      <p:ext uri="{BB962C8B-B14F-4D97-AF65-F5344CB8AC3E}">
+        <p14:creationId xmlns:p14="http://schemas.microsoft.com/office/powerpoint/2010/main" val="3107085698"/>
+      </p:ext>
+    </p:extLst>
+  </p:cSld>
+  <p:clrMapOvr>
+    <a:masterClrMapping/>
+  </p:clrMapOvr>
+</p:sld>
+</file>
+
+<file path=ppt/slides/slide11.xml><?xml version="1.0" encoding="utf-8"?>
+<p:sld xmlns:a="http://schemas.openxmlformats.org/drawingml/2006/main" xmlns:r="http://schemas.openxmlformats.org/officeDocument/2006/relationships" xmlns:p="http://schemas.openxmlformats.org/presentationml/2006/main">
+  <p:cSld>
+    <p:spTree>
+      <p:nvGrpSpPr>
+        <p:cNvPr id="1" name=""/>
+        <p:cNvGrpSpPr/>
+        <p:nvPr/>
+      </p:nvGrpSpPr>
+      <p:grpSpPr>
+        <a:xfrm>
+          <a:off x="0" y="0"/>
+          <a:ext cx="0" cy="0"/>
+          <a:chOff x="0" y="0"/>
+          <a:chExt cx="0" cy="0"/>
+        </a:xfrm>
+      </p:grpSpPr>
+      <p:sp>
+        <p:nvSpPr>
+          <p:cNvPr id="2" name="Title 1">
+            <a:extLst>
+              <a:ext uri="{FF2B5EF4-FFF2-40B4-BE49-F238E27FC236}">
+                <a16:creationId xmlns:a16="http://schemas.microsoft.com/office/drawing/2014/main" id="{3895B8B6-206B-7D3C-4ABE-6A0B95A7A5B5}"/>
+              </a:ext>
+            </a:extLst>
+          </p:cNvPr>
+          <p:cNvSpPr>
+            <a:spLocks noGrp="1"/>
+          </p:cNvSpPr>
+          <p:nvPr>
+            <p:ph type="title"/>
+          </p:nvPr>
+        </p:nvSpPr>
+        <p:spPr/>
+        <p:txBody>
+          <a:bodyPr/>
+          <a:lstStyle/>
+          <a:p>
+            <a:endParaRPr lang="en-001"/>
+          </a:p>
+        </p:txBody>
+      </p:sp>
+      <p:pic>
+        <p:nvPicPr>
+          <p:cNvPr id="5" name="Content Placeholder 4">
+            <a:extLst>
+              <a:ext uri="{FF2B5EF4-FFF2-40B4-BE49-F238E27FC236}">
+                <a16:creationId xmlns:a16="http://schemas.microsoft.com/office/drawing/2014/main" id="{8D5AECDB-ABFC-D5F9-5E1F-8FC9C8281233}"/>
+              </a:ext>
+            </a:extLst>
+          </p:cNvPr>
+          <p:cNvPicPr>
+            <a:picLocks noGrp="1" noChangeAspect="1"/>
+          </p:cNvPicPr>
+          <p:nvPr>
+            <p:ph idx="1"/>
+          </p:nvPr>
+        </p:nvPicPr>
+        <p:blipFill>
+          <a:blip r:embed="rId3">
+            <a:extLst>
+              <a:ext uri="{28A0092B-C50C-407E-A947-70E740481C1C}">
+                <a14:useLocalDpi xmlns:a14="http://schemas.microsoft.com/office/drawing/2010/main" val="0"/>
+              </a:ext>
+            </a:extLst>
+          </a:blip>
+          <a:stretch>
+            <a:fillRect/>
+          </a:stretch>
+        </p:blipFill>
+        <p:spPr>
+          <a:xfrm>
+            <a:off x="0" y="0"/>
+            <a:ext cx="12192000" cy="6858000"/>
+          </a:xfrm>
+        </p:spPr>
+      </p:pic>
+    </p:spTree>
+    <p:extLst>
+      <p:ext uri="{BB962C8B-B14F-4D97-AF65-F5344CB8AC3E}">
+        <p14:creationId xmlns:p14="http://schemas.microsoft.com/office/powerpoint/2010/main" val="1567706787"/>
+      </p:ext>
+    </p:extLst>
+  </p:cSld>
+  <p:clrMapOvr>
+    <a:masterClrMapping/>
+  </p:clrMapOvr>
+</p:sld>
+</file>
+
+<file path=ppt/slides/slide12.xml><?xml version="1.0" encoding="utf-8"?>
+<p:sld xmlns:a="http://schemas.openxmlformats.org/drawingml/2006/main" xmlns:r="http://schemas.openxmlformats.org/officeDocument/2006/relationships" xmlns:p="http://schemas.openxmlformats.org/presentationml/2006/main">
+  <p:cSld>
+    <p:spTree>
+      <p:nvGrpSpPr>
+        <p:cNvPr id="1" name=""/>
+        <p:cNvGrpSpPr/>
+        <p:nvPr/>
+      </p:nvGrpSpPr>
+      <p:grpSpPr>
+        <a:xfrm>
+          <a:off x="0" y="0"/>
+          <a:ext cx="0" cy="0"/>
+          <a:chOff x="0" y="0"/>
+          <a:chExt cx="0" cy="0"/>
+        </a:xfrm>
+      </p:grpSpPr>
+      <p:pic>
+        <p:nvPicPr>
+          <p:cNvPr id="8" name="Picture 7">
+            <a:extLst>
+              <a:ext uri="{FF2B5EF4-FFF2-40B4-BE49-F238E27FC236}">
+                <a16:creationId xmlns:a16="http://schemas.microsoft.com/office/drawing/2014/main" id="{7E2E2342-529B-A456-EE2B-0087C69B1CA0}"/>
+              </a:ext>
+            </a:extLst>
+          </p:cNvPr>
+          <p:cNvPicPr>
+            <a:picLocks noChangeAspect="1"/>
+          </p:cNvPicPr>
+          <p:nvPr/>
+        </p:nvPicPr>
+        <p:blipFill>
+          <a:blip r:embed="rId2"/>
+          <a:stretch>
+            <a:fillRect/>
+          </a:stretch>
+        </p:blipFill>
+        <p:spPr>
+          <a:xfrm>
+            <a:off x="0" y="0"/>
+            <a:ext cx="12192000" cy="6858000"/>
+          </a:xfrm>
+          <a:prstGeom prst="rect">
+            <a:avLst/>
+          </a:prstGeom>
+        </p:spPr>
+      </p:pic>
+    </p:spTree>
+    <p:extLst>
+      <p:ext uri="{BB962C8B-B14F-4D97-AF65-F5344CB8AC3E}">
+        <p14:creationId xmlns:p14="http://schemas.microsoft.com/office/powerpoint/2010/main" val="1794376672"/>
+      </p:ext>
+    </p:extLst>
+  </p:cSld>
+  <p:clrMapOvr>
+    <a:masterClrMapping/>
+  </p:clrMapOvr>
+</p:sld>
+</file>
+
+<file path=ppt/slides/slide13.xml><?xml version="1.0" encoding="utf-8"?>
+<p:sld xmlns:a="http://schemas.openxmlformats.org/drawingml/2006/main" xmlns:r="http://schemas.openxmlformats.org/officeDocument/2006/relationships" xmlns:p="http://schemas.openxmlformats.org/presentationml/2006/main">
+  <p:cSld>
+    <p:spTree>
+      <p:nvGrpSpPr>
+        <p:cNvPr id="1" name=""/>
+        <p:cNvGrpSpPr/>
+        <p:nvPr/>
+      </p:nvGrpSpPr>
+      <p:grpSpPr>
+        <a:xfrm>
+          <a:off x="0" y="0"/>
+          <a:ext cx="0" cy="0"/>
+          <a:chOff x="0" y="0"/>
+          <a:chExt cx="0" cy="0"/>
+        </a:xfrm>
+      </p:grpSpPr>
+      <p:sp>
+        <p:nvSpPr>
+          <p:cNvPr id="10" name="Title 1">
+            <a:extLst>
+              <a:ext uri="{FF2B5EF4-FFF2-40B4-BE49-F238E27FC236}">
+                <a16:creationId xmlns:a16="http://schemas.microsoft.com/office/drawing/2014/main" id="{3827BC4F-E76F-322A-E24F-7DBDA3DB63CA}"/>
+              </a:ext>
+            </a:extLst>
+          </p:cNvPr>
+          <p:cNvSpPr>
+            <a:spLocks noGrp="1"/>
+          </p:cNvSpPr>
+          <p:nvPr>
+            <p:ph type="title"/>
+          </p:nvPr>
+        </p:nvSpPr>
+        <p:spPr>
+          <a:xfrm>
+            <a:off x="838200" y="365125"/>
+            <a:ext cx="10515600" cy="1325563"/>
+          </a:xfrm>
+        </p:spPr>
+        <p:txBody>
+          <a:bodyPr/>
+          <a:lstStyle/>
+          <a:p>
+            <a:r>
+              <a:rPr lang="en-US" dirty="0"/>
+              <a:t>End of term expectations</a:t>
+            </a:r>
+            <a:endParaRPr lang="en-001" dirty="0"/>
+          </a:p>
+        </p:txBody>
+      </p:sp>
+      <p:sp>
+        <p:nvSpPr>
+          <p:cNvPr id="11" name="Content Placeholder 2">
+            <a:extLst>
+              <a:ext uri="{FF2B5EF4-FFF2-40B4-BE49-F238E27FC236}">
+                <a16:creationId xmlns:a16="http://schemas.microsoft.com/office/drawing/2014/main" id="{84FBA1D4-E276-C1B1-4E98-CCAAC2A4E39E}"/>
+              </a:ext>
+            </a:extLst>
+          </p:cNvPr>
+          <p:cNvSpPr>
+            <a:spLocks noGrp="1"/>
+          </p:cNvSpPr>
+          <p:nvPr>
+            <p:ph idx="1"/>
+          </p:nvPr>
+        </p:nvSpPr>
+        <p:spPr>
+          <a:xfrm>
+            <a:off x="838200" y="1825625"/>
+            <a:ext cx="5626608" cy="4351338"/>
+          </a:xfrm>
+        </p:spPr>
+        <p:txBody>
+          <a:bodyPr>
+            <a:normAutofit/>
+          </a:bodyPr>
+          <a:lstStyle/>
+          <a:p>
+            <a:r>
+              <a:rPr lang="en-US" dirty="0"/>
+              <a:t>API:</a:t>
+            </a:r>
+          </a:p>
+          <a:p>
+            <a:pPr lvl="1"/>
+            <a:r>
+              <a:rPr lang="en-US" dirty="0"/>
+              <a:t>Helm (Kubernetes) integration</a:t>
+            </a:r>
+          </a:p>
+          <a:p>
+            <a:pPr lvl="1"/>
+            <a:r>
+              <a:rPr lang="en-US" dirty="0"/>
+              <a:t>Testing suite</a:t>
+            </a:r>
+          </a:p>
+          <a:p>
+            <a:pPr lvl="1"/>
+            <a:r>
+              <a:rPr lang="en-US" dirty="0"/>
+              <a:t>Alternative services/configuration:</a:t>
+            </a:r>
+          </a:p>
+          <a:p>
+            <a:pPr lvl="2"/>
+            <a:r>
+              <a:rPr lang="en-US" dirty="0"/>
+              <a:t>Larger model for </a:t>
+            </a:r>
+            <a:r>
+              <a:rPr lang="en-US" dirty="0" err="1"/>
+              <a:t>sglang</a:t>
+            </a:r>
+            <a:r>
+              <a:rPr lang="en-US" dirty="0"/>
+              <a:t>.</a:t>
+            </a:r>
+          </a:p>
+          <a:p>
+            <a:pPr lvl="2"/>
+            <a:r>
+              <a:rPr lang="en-US" dirty="0"/>
+              <a:t>Postgres (instead of </a:t>
+            </a:r>
+            <a:r>
+              <a:rPr lang="en-US" dirty="0" err="1"/>
+              <a:t>sqlite</a:t>
+            </a:r>
+            <a:r>
+              <a:rPr lang="en-US" dirty="0"/>
+              <a:t>).</a:t>
+            </a:r>
+          </a:p>
+          <a:p>
+            <a:pPr lvl="2"/>
+            <a:r>
+              <a:rPr lang="en-US" dirty="0"/>
+              <a:t>Non-AWS based file storage – either Redis or Postgres(BYTEA col).</a:t>
+            </a:r>
+          </a:p>
+          <a:p>
+            <a:pPr lvl="1"/>
+            <a:r>
+              <a:rPr lang="en-US" dirty="0"/>
+              <a:t>Text extraction step for pdfs needs to not be repeated.</a:t>
+            </a:r>
+          </a:p>
+        </p:txBody>
+      </p:sp>
+      <p:sp>
+        <p:nvSpPr>
+          <p:cNvPr id="12" name="Content Placeholder 2">
+            <a:extLst>
+              <a:ext uri="{FF2B5EF4-FFF2-40B4-BE49-F238E27FC236}">
+                <a16:creationId xmlns:a16="http://schemas.microsoft.com/office/drawing/2014/main" id="{AA62BDE5-8A4F-2C44-762D-AD609EE634CE}"/>
+              </a:ext>
+            </a:extLst>
+          </p:cNvPr>
+          <p:cNvSpPr txBox="1">
+            <a:spLocks/>
+          </p:cNvSpPr>
+          <p:nvPr/>
+        </p:nvSpPr>
+        <p:spPr>
+          <a:xfrm>
+            <a:off x="6464808" y="1825625"/>
+            <a:ext cx="5257800" cy="4351338"/>
+          </a:xfrm>
+          <a:prstGeom prst="rect">
+            <a:avLst/>
+          </a:prstGeom>
+        </p:spPr>
+        <p:txBody>
+          <a:bodyPr vert="horz" lIns="91440" tIns="45720" rIns="91440" bIns="45720" rtlCol="0">
+            <a:normAutofit/>
+          </a:bodyPr>
+          <a:lstStyle>
+            <a:lvl1pPr marL="228600" indent="-228600" algn="l" defTabSz="914400" rtl="0" eaLnBrk="1" latinLnBrk="0" hangingPunct="1">
+              <a:lnSpc>
+                <a:spcPct val="90000"/>
+              </a:lnSpc>
+              <a:spcBef>
+                <a:spcPts val="1000"/>
+              </a:spcBef>
+              <a:buFont typeface="Arial" panose="020B0604020202020204" pitchFamily="34" charset="0"/>
+              <a:buChar char="•"/>
+              <a:defRPr sz="2800" kern="1200">
+                <a:solidFill>
+                  <a:schemeClr val="tx1"/>
+                </a:solidFill>
+                <a:latin typeface="+mn-lt"/>
+                <a:ea typeface="+mn-ea"/>
+                <a:cs typeface="+mn-cs"/>
+              </a:defRPr>
+            </a:lvl1pPr>
+            <a:lvl2pPr marL="685800" indent="-228600" algn="l" defTabSz="914400" rtl="0" eaLnBrk="1" latinLnBrk="0" hangingPunct="1">
+              <a:lnSpc>
+                <a:spcPct val="90000"/>
+              </a:lnSpc>
+              <a:spcBef>
+                <a:spcPts val="500"/>
+              </a:spcBef>
+              <a:buFont typeface="Arial" panose="020B0604020202020204" pitchFamily="34" charset="0"/>
+              <a:buChar char="•"/>
+              <a:defRPr sz="2400" kern="1200">
+                <a:solidFill>
+                  <a:schemeClr val="tx1"/>
+                </a:solidFill>
+                <a:latin typeface="+mn-lt"/>
+                <a:ea typeface="+mn-ea"/>
+                <a:cs typeface="+mn-cs"/>
+              </a:defRPr>
+            </a:lvl2pPr>
+            <a:lvl3pPr marL="1143000" indent="-228600" algn="l" defTabSz="914400" rtl="0" eaLnBrk="1" latinLnBrk="0" hangingPunct="1">
+              <a:lnSpc>
+                <a:spcPct val="90000"/>
+              </a:lnSpc>
+              <a:spcBef>
+                <a:spcPts val="500"/>
+              </a:spcBef>
+              <a:buFont typeface="Arial" panose="020B0604020202020204" pitchFamily="34" charset="0"/>
+              <a:buChar char="•"/>
+              <a:defRPr sz="2000" kern="1200">
+                <a:solidFill>
+                  <a:schemeClr val="tx1"/>
+                </a:solidFill>
+                <a:latin typeface="+mn-lt"/>
+                <a:ea typeface="+mn-ea"/>
+                <a:cs typeface="+mn-cs"/>
+              </a:defRPr>
+            </a:lvl3pPr>
+            <a:lvl4pPr marL="1600200" indent="-228600" algn="l" defTabSz="914400" rtl="0" eaLnBrk="1" latinLnBrk="0" hangingPunct="1">
+              <a:lnSpc>
+                <a:spcPct val="90000"/>
+              </a:lnSpc>
+              <a:spcBef>
+                <a:spcPts val="500"/>
+              </a:spcBef>
+              <a:buFont typeface="Arial" panose="020B0604020202020204" pitchFamily="34" charset="0"/>
+              <a:buChar char="•"/>
+              <a:defRPr sz="1800" kern="1200">
+                <a:solidFill>
+                  <a:schemeClr val="tx1"/>
+                </a:solidFill>
+                <a:latin typeface="+mn-lt"/>
+                <a:ea typeface="+mn-ea"/>
+                <a:cs typeface="+mn-cs"/>
+              </a:defRPr>
+            </a:lvl4pPr>
+            <a:lvl5pPr marL="2057400" indent="-228600" algn="l" defTabSz="914400" rtl="0" eaLnBrk="1" latinLnBrk="0" hangingPunct="1">
+              <a:lnSpc>
+                <a:spcPct val="90000"/>
+              </a:lnSpc>
+              <a:spcBef>
+                <a:spcPts val="500"/>
+              </a:spcBef>
+              <a:buFont typeface="Arial" panose="020B0604020202020204" pitchFamily="34" charset="0"/>
+              <a:buChar char="•"/>
+              <a:defRPr sz="1800" kern="1200">
+                <a:solidFill>
+                  <a:schemeClr val="tx1"/>
+                </a:solidFill>
+                <a:latin typeface="+mn-lt"/>
+                <a:ea typeface="+mn-ea"/>
+                <a:cs typeface="+mn-cs"/>
+              </a:defRPr>
+            </a:lvl5pPr>
+            <a:lvl6pPr marL="2514600" indent="-228600" algn="l" defTabSz="914400" rtl="0" eaLnBrk="1" latinLnBrk="0" hangingPunct="1">
+              <a:lnSpc>
+                <a:spcPct val="90000"/>
+              </a:lnSpc>
+              <a:spcBef>
+                <a:spcPts val="500"/>
+              </a:spcBef>
+              <a:buFont typeface="Arial" panose="020B0604020202020204" pitchFamily="34" charset="0"/>
+              <a:buChar char="•"/>
+              <a:defRPr sz="1800" kern="1200">
+                <a:solidFill>
+                  <a:schemeClr val="tx1"/>
+                </a:solidFill>
+                <a:latin typeface="+mn-lt"/>
+                <a:ea typeface="+mn-ea"/>
+                <a:cs typeface="+mn-cs"/>
+              </a:defRPr>
+            </a:lvl6pPr>
+            <a:lvl7pPr marL="2971800" indent="-228600" algn="l" defTabSz="914400" rtl="0" eaLnBrk="1" latinLnBrk="0" hangingPunct="1">
+              <a:lnSpc>
+                <a:spcPct val="90000"/>
+              </a:lnSpc>
+              <a:spcBef>
+                <a:spcPts val="500"/>
+              </a:spcBef>
+              <a:buFont typeface="Arial" panose="020B0604020202020204" pitchFamily="34" charset="0"/>
+              <a:buChar char="•"/>
+              <a:defRPr sz="1800" kern="1200">
+                <a:solidFill>
+                  <a:schemeClr val="tx1"/>
+                </a:solidFill>
+                <a:latin typeface="+mn-lt"/>
+                <a:ea typeface="+mn-ea"/>
+                <a:cs typeface="+mn-cs"/>
+              </a:defRPr>
+            </a:lvl7pPr>
+            <a:lvl8pPr marL="3429000" indent="-228600" algn="l" defTabSz="914400" rtl="0" eaLnBrk="1" latinLnBrk="0" hangingPunct="1">
+              <a:lnSpc>
+                <a:spcPct val="90000"/>
+              </a:lnSpc>
+              <a:spcBef>
+                <a:spcPts val="500"/>
+              </a:spcBef>
+              <a:buFont typeface="Arial" panose="020B0604020202020204" pitchFamily="34" charset="0"/>
+              <a:buChar char="•"/>
+              <a:defRPr sz="1800" kern="1200">
+                <a:solidFill>
+                  <a:schemeClr val="tx1"/>
+                </a:solidFill>
+                <a:latin typeface="+mn-lt"/>
+                <a:ea typeface="+mn-ea"/>
+                <a:cs typeface="+mn-cs"/>
+              </a:defRPr>
+            </a:lvl8pPr>
+            <a:lvl9pPr marL="3886200" indent="-228600" algn="l" defTabSz="914400" rtl="0" eaLnBrk="1" latinLnBrk="0" hangingPunct="1">
+              <a:lnSpc>
+                <a:spcPct val="90000"/>
+              </a:lnSpc>
+              <a:spcBef>
+                <a:spcPts val="500"/>
+              </a:spcBef>
+              <a:buFont typeface="Arial" panose="020B0604020202020204" pitchFamily="34" charset="0"/>
+              <a:buChar char="•"/>
+              <a:defRPr sz="1800" kern="1200">
+                <a:solidFill>
+                  <a:schemeClr val="tx1"/>
+                </a:solidFill>
+                <a:latin typeface="+mn-lt"/>
+                <a:ea typeface="+mn-ea"/>
+                <a:cs typeface="+mn-cs"/>
+              </a:defRPr>
+            </a:lvl9pPr>
+          </a:lstStyle>
+          <a:p>
+            <a:r>
+              <a:rPr lang="en-US" dirty="0"/>
+              <a:t>Client</a:t>
+            </a:r>
+          </a:p>
+          <a:p>
+            <a:pPr lvl="1"/>
+            <a:r>
+              <a:rPr lang="en-US" dirty="0"/>
+              <a:t>Testing (both client unit testing and E2E.</a:t>
+            </a:r>
+          </a:p>
+          <a:p>
+            <a:r>
+              <a:rPr lang="en-US" dirty="0"/>
+              <a:t>Game (essentially untouched):</a:t>
+            </a:r>
+          </a:p>
+          <a:p>
+            <a:pPr lvl="1"/>
+            <a:r>
+              <a:rPr lang="en-US" dirty="0"/>
+              <a:t>Assets</a:t>
+            </a:r>
+          </a:p>
+          <a:p>
+            <a:pPr lvl="1"/>
+            <a:r>
+              <a:rPr lang="en-US" dirty="0"/>
+              <a:t>Rending</a:t>
+            </a:r>
+          </a:p>
+          <a:p>
+            <a:pPr lvl="1"/>
+            <a:r>
+              <a:rPr lang="en-US" dirty="0"/>
+              <a:t>Input</a:t>
+            </a:r>
+          </a:p>
+          <a:p>
+            <a:pPr lvl="1"/>
+            <a:r>
+              <a:rPr lang="en-US" dirty="0"/>
+              <a:t>Scripting actual gameplay</a:t>
+            </a:r>
+          </a:p>
+          <a:p>
+            <a:r>
+              <a:rPr lang="en-US" dirty="0"/>
+              <a:t>Deployment</a:t>
+            </a:r>
+          </a:p>
+        </p:txBody>
+      </p:sp>
+    </p:spTree>
+    <p:extLst>
+      <p:ext uri="{BB962C8B-B14F-4D97-AF65-F5344CB8AC3E}">
+        <p14:creationId xmlns:p14="http://schemas.microsoft.com/office/powerpoint/2010/main" val="1089732749"/>
+      </p:ext>
+    </p:extLst>
+  </p:cSld>
+  <p:clrMapOvr>
+    <a:masterClrMapping/>
+  </p:clrMapOvr>
+</p:sld>
+</file>
+
+<file path=ppt/slides/slide14.xml><?xml version="1.0" encoding="utf-8"?>
+<p:sld xmlns:a="http://schemas.openxmlformats.org/drawingml/2006/main" xmlns:r="http://schemas.openxmlformats.org/officeDocument/2006/relationships" xmlns:p="http://schemas.openxmlformats.org/presentationml/2006/main">
+  <p:cSld>
+    <p:spTree>
+      <p:nvGrpSpPr>
+        <p:cNvPr id="1" name=""/>
+        <p:cNvGrpSpPr/>
+        <p:nvPr/>
+      </p:nvGrpSpPr>
+      <p:grpSpPr>
+        <a:xfrm>
+          <a:off x="0" y="0"/>
+          <a:ext cx="0" cy="0"/>
+          <a:chOff x="0" y="0"/>
+          <a:chExt cx="0" cy="0"/>
+        </a:xfrm>
+      </p:grpSpPr>
+      <p:sp>
+        <p:nvSpPr>
+          <p:cNvPr id="2" name="Title 1">
+            <a:extLst>
+              <a:ext uri="{FF2B5EF4-FFF2-40B4-BE49-F238E27FC236}">
                 <a16:creationId xmlns:a16="http://schemas.microsoft.com/office/drawing/2014/main" id="{18654137-EF46-9031-5EF7-5D0D666D3A75}"/>
               </a:ext>
             </a:extLst>
@@ -4518,28 +5555,384 @@
             <p:ph idx="1"/>
           </p:nvPr>
         </p:nvSpPr>
-        <p:spPr/>
-        <p:txBody>
-          <a:bodyPr/>
-          <a:lstStyle/>
-          <a:p>
-            <a:r>
-              <a:rPr lang="en-US" dirty="0"/>
-              <a:t>Have all file-based uploads completed</a:t>
-            </a:r>
-          </a:p>
-          <a:p>
-            <a:r>
-              <a:rPr lang="en-US" dirty="0"/>
-              <a:t>Full complete guest and user session relation for users joining through a game code.</a:t>
-            </a:r>
-          </a:p>
-          <a:p>
-            <a:r>
-              <a:rPr lang="en-US" dirty="0"/>
-              <a:t>Have all LLM-powered backend features fill implemented</a:t>
-            </a:r>
-            <a:endParaRPr lang="en-001" dirty="0"/>
+        <p:spPr>
+          <a:xfrm>
+            <a:off x="838200" y="1825625"/>
+            <a:ext cx="5626608" cy="4351338"/>
+          </a:xfrm>
+        </p:spPr>
+        <p:txBody>
+          <a:bodyPr>
+            <a:normAutofit/>
+          </a:bodyPr>
+          <a:lstStyle/>
+          <a:p>
+            <a:r>
+              <a:rPr lang="en-US" dirty="0"/>
+              <a:t>API:</a:t>
+            </a:r>
+          </a:p>
+          <a:p>
+            <a:pPr lvl="1"/>
+            <a:r>
+              <a:rPr lang="en-US" dirty="0"/>
+              <a:t>Helm (Kubernetes) integration</a:t>
+            </a:r>
+          </a:p>
+          <a:p>
+            <a:pPr lvl="1"/>
+            <a:r>
+              <a:rPr lang="en-US" dirty="0">
+                <a:highlight>
+                  <a:srgbClr val="FFFF00"/>
+                </a:highlight>
+              </a:rPr>
+              <a:t>Testing suite</a:t>
+            </a:r>
+          </a:p>
+          <a:p>
+            <a:pPr lvl="1"/>
+            <a:r>
+              <a:rPr lang="en-US" dirty="0">
+                <a:highlight>
+                  <a:srgbClr val="FFFF00"/>
+                </a:highlight>
+              </a:rPr>
+              <a:t>Alternative services/configuration:</a:t>
+            </a:r>
+          </a:p>
+          <a:p>
+            <a:pPr lvl="2"/>
+            <a:r>
+              <a:rPr lang="en-US" dirty="0">
+                <a:highlight>
+                  <a:srgbClr val="FFFF00"/>
+                </a:highlight>
+              </a:rPr>
+              <a:t>Larger model for </a:t>
+            </a:r>
+            <a:r>
+              <a:rPr lang="en-US" dirty="0" err="1">
+                <a:highlight>
+                  <a:srgbClr val="FFFF00"/>
+                </a:highlight>
+              </a:rPr>
+              <a:t>sglang</a:t>
+            </a:r>
+            <a:r>
+              <a:rPr lang="en-US" dirty="0">
+                <a:highlight>
+                  <a:srgbClr val="FFFF00"/>
+                </a:highlight>
+              </a:rPr>
+              <a:t>.</a:t>
+            </a:r>
+          </a:p>
+          <a:p>
+            <a:pPr lvl="2"/>
+            <a:r>
+              <a:rPr lang="en-US" dirty="0">
+                <a:highlight>
+                  <a:srgbClr val="FFFF00"/>
+                </a:highlight>
+              </a:rPr>
+              <a:t>Postgres (instead of </a:t>
+            </a:r>
+            <a:r>
+              <a:rPr lang="en-US" dirty="0" err="1">
+                <a:highlight>
+                  <a:srgbClr val="FFFF00"/>
+                </a:highlight>
+              </a:rPr>
+              <a:t>sqlite</a:t>
+            </a:r>
+            <a:r>
+              <a:rPr lang="en-US" dirty="0">
+                <a:highlight>
+                  <a:srgbClr val="FFFF00"/>
+                </a:highlight>
+              </a:rPr>
+              <a:t>).</a:t>
+            </a:r>
+          </a:p>
+          <a:p>
+            <a:pPr lvl="2"/>
+            <a:r>
+              <a:rPr lang="en-US" dirty="0">
+                <a:highlight>
+                  <a:srgbClr val="FFFF00"/>
+                </a:highlight>
+              </a:rPr>
+              <a:t>Non-AWS based file storage – either Redis or Postgres(BYTEA col).</a:t>
+            </a:r>
+          </a:p>
+          <a:p>
+            <a:pPr lvl="1"/>
+            <a:r>
+              <a:rPr lang="en-US" dirty="0">
+                <a:highlight>
+                  <a:srgbClr val="FFFF00"/>
+                </a:highlight>
+              </a:rPr>
+              <a:t>Text extraction step for pdfs needs to not be repeated.</a:t>
+            </a:r>
+          </a:p>
+        </p:txBody>
+      </p:sp>
+      <p:sp>
+        <p:nvSpPr>
+          <p:cNvPr id="4" name="Content Placeholder 2">
+            <a:extLst>
+              <a:ext uri="{FF2B5EF4-FFF2-40B4-BE49-F238E27FC236}">
+                <a16:creationId xmlns:a16="http://schemas.microsoft.com/office/drawing/2014/main" id="{932E9928-FB79-0AA9-1492-DCB01E50C059}"/>
+              </a:ext>
+            </a:extLst>
+          </p:cNvPr>
+          <p:cNvSpPr txBox="1">
+            <a:spLocks/>
+          </p:cNvSpPr>
+          <p:nvPr/>
+        </p:nvSpPr>
+        <p:spPr>
+          <a:xfrm>
+            <a:off x="6464808" y="1825625"/>
+            <a:ext cx="5257800" cy="4351338"/>
+          </a:xfrm>
+          <a:prstGeom prst="rect">
+            <a:avLst/>
+          </a:prstGeom>
+        </p:spPr>
+        <p:txBody>
+          <a:bodyPr vert="horz" lIns="91440" tIns="45720" rIns="91440" bIns="45720" rtlCol="0">
+            <a:normAutofit/>
+          </a:bodyPr>
+          <a:lstStyle>
+            <a:lvl1pPr marL="228600" indent="-228600" algn="l" defTabSz="914400" rtl="0" eaLnBrk="1" latinLnBrk="0" hangingPunct="1">
+              <a:lnSpc>
+                <a:spcPct val="90000"/>
+              </a:lnSpc>
+              <a:spcBef>
+                <a:spcPts val="1000"/>
+              </a:spcBef>
+              <a:buFont typeface="Arial" panose="020B0604020202020204" pitchFamily="34" charset="0"/>
+              <a:buChar char="•"/>
+              <a:defRPr sz="2800" kern="1200">
+                <a:solidFill>
+                  <a:schemeClr val="tx1"/>
+                </a:solidFill>
+                <a:latin typeface="+mn-lt"/>
+                <a:ea typeface="+mn-ea"/>
+                <a:cs typeface="+mn-cs"/>
+              </a:defRPr>
+            </a:lvl1pPr>
+            <a:lvl2pPr marL="685800" indent="-228600" algn="l" defTabSz="914400" rtl="0" eaLnBrk="1" latinLnBrk="0" hangingPunct="1">
+              <a:lnSpc>
+                <a:spcPct val="90000"/>
+              </a:lnSpc>
+              <a:spcBef>
+                <a:spcPts val="500"/>
+              </a:spcBef>
+              <a:buFont typeface="Arial" panose="020B0604020202020204" pitchFamily="34" charset="0"/>
+              <a:buChar char="•"/>
+              <a:defRPr sz="2400" kern="1200">
+                <a:solidFill>
+                  <a:schemeClr val="tx1"/>
+                </a:solidFill>
+                <a:latin typeface="+mn-lt"/>
+                <a:ea typeface="+mn-ea"/>
+                <a:cs typeface="+mn-cs"/>
+              </a:defRPr>
+            </a:lvl2pPr>
+            <a:lvl3pPr marL="1143000" indent="-228600" algn="l" defTabSz="914400" rtl="0" eaLnBrk="1" latinLnBrk="0" hangingPunct="1">
+              <a:lnSpc>
+                <a:spcPct val="90000"/>
+              </a:lnSpc>
+              <a:spcBef>
+                <a:spcPts val="500"/>
+              </a:spcBef>
+              <a:buFont typeface="Arial" panose="020B0604020202020204" pitchFamily="34" charset="0"/>
+              <a:buChar char="•"/>
+              <a:defRPr sz="2000" kern="1200">
+                <a:solidFill>
+                  <a:schemeClr val="tx1"/>
+                </a:solidFill>
+                <a:latin typeface="+mn-lt"/>
+                <a:ea typeface="+mn-ea"/>
+                <a:cs typeface="+mn-cs"/>
+              </a:defRPr>
+            </a:lvl3pPr>
+            <a:lvl4pPr marL="1600200" indent="-228600" algn="l" defTabSz="914400" rtl="0" eaLnBrk="1" latinLnBrk="0" hangingPunct="1">
+              <a:lnSpc>
+                <a:spcPct val="90000"/>
+              </a:lnSpc>
+              <a:spcBef>
+                <a:spcPts val="500"/>
+              </a:spcBef>
+              <a:buFont typeface="Arial" panose="020B0604020202020204" pitchFamily="34" charset="0"/>
+              <a:buChar char="•"/>
+              <a:defRPr sz="1800" kern="1200">
+                <a:solidFill>
+                  <a:schemeClr val="tx1"/>
+                </a:solidFill>
+                <a:latin typeface="+mn-lt"/>
+                <a:ea typeface="+mn-ea"/>
+                <a:cs typeface="+mn-cs"/>
+              </a:defRPr>
+            </a:lvl4pPr>
+            <a:lvl5pPr marL="2057400" indent="-228600" algn="l" defTabSz="914400" rtl="0" eaLnBrk="1" latinLnBrk="0" hangingPunct="1">
+              <a:lnSpc>
+                <a:spcPct val="90000"/>
+              </a:lnSpc>
+              <a:spcBef>
+                <a:spcPts val="500"/>
+              </a:spcBef>
+              <a:buFont typeface="Arial" panose="020B0604020202020204" pitchFamily="34" charset="0"/>
+              <a:buChar char="•"/>
+              <a:defRPr sz="1800" kern="1200">
+                <a:solidFill>
+                  <a:schemeClr val="tx1"/>
+                </a:solidFill>
+                <a:latin typeface="+mn-lt"/>
+                <a:ea typeface="+mn-ea"/>
+                <a:cs typeface="+mn-cs"/>
+              </a:defRPr>
+            </a:lvl5pPr>
+            <a:lvl6pPr marL="2514600" indent="-228600" algn="l" defTabSz="914400" rtl="0" eaLnBrk="1" latinLnBrk="0" hangingPunct="1">
+              <a:lnSpc>
+                <a:spcPct val="90000"/>
+              </a:lnSpc>
+              <a:spcBef>
+                <a:spcPts val="500"/>
+              </a:spcBef>
+              <a:buFont typeface="Arial" panose="020B0604020202020204" pitchFamily="34" charset="0"/>
+              <a:buChar char="•"/>
+              <a:defRPr sz="1800" kern="1200">
+                <a:solidFill>
+                  <a:schemeClr val="tx1"/>
+                </a:solidFill>
+                <a:latin typeface="+mn-lt"/>
+                <a:ea typeface="+mn-ea"/>
+                <a:cs typeface="+mn-cs"/>
+              </a:defRPr>
+            </a:lvl6pPr>
+            <a:lvl7pPr marL="2971800" indent="-228600" algn="l" defTabSz="914400" rtl="0" eaLnBrk="1" latinLnBrk="0" hangingPunct="1">
+              <a:lnSpc>
+                <a:spcPct val="90000"/>
+              </a:lnSpc>
+              <a:spcBef>
+                <a:spcPts val="500"/>
+              </a:spcBef>
+              <a:buFont typeface="Arial" panose="020B0604020202020204" pitchFamily="34" charset="0"/>
+              <a:buChar char="•"/>
+              <a:defRPr sz="1800" kern="1200">
+                <a:solidFill>
+                  <a:schemeClr val="tx1"/>
+                </a:solidFill>
+                <a:latin typeface="+mn-lt"/>
+                <a:ea typeface="+mn-ea"/>
+                <a:cs typeface="+mn-cs"/>
+              </a:defRPr>
+            </a:lvl7pPr>
+            <a:lvl8pPr marL="3429000" indent="-228600" algn="l" defTabSz="914400" rtl="0" eaLnBrk="1" latinLnBrk="0" hangingPunct="1">
+              <a:lnSpc>
+                <a:spcPct val="90000"/>
+              </a:lnSpc>
+              <a:spcBef>
+                <a:spcPts val="500"/>
+              </a:spcBef>
+              <a:buFont typeface="Arial" panose="020B0604020202020204" pitchFamily="34" charset="0"/>
+              <a:buChar char="•"/>
+              <a:defRPr sz="1800" kern="1200">
+                <a:solidFill>
+                  <a:schemeClr val="tx1"/>
+                </a:solidFill>
+                <a:latin typeface="+mn-lt"/>
+                <a:ea typeface="+mn-ea"/>
+                <a:cs typeface="+mn-cs"/>
+              </a:defRPr>
+            </a:lvl8pPr>
+            <a:lvl9pPr marL="3886200" indent="-228600" algn="l" defTabSz="914400" rtl="0" eaLnBrk="1" latinLnBrk="0" hangingPunct="1">
+              <a:lnSpc>
+                <a:spcPct val="90000"/>
+              </a:lnSpc>
+              <a:spcBef>
+                <a:spcPts val="500"/>
+              </a:spcBef>
+              <a:buFont typeface="Arial" panose="020B0604020202020204" pitchFamily="34" charset="0"/>
+              <a:buChar char="•"/>
+              <a:defRPr sz="1800" kern="1200">
+                <a:solidFill>
+                  <a:schemeClr val="tx1"/>
+                </a:solidFill>
+                <a:latin typeface="+mn-lt"/>
+                <a:ea typeface="+mn-ea"/>
+                <a:cs typeface="+mn-cs"/>
+              </a:defRPr>
+            </a:lvl9pPr>
+          </a:lstStyle>
+          <a:p>
+            <a:r>
+              <a:rPr lang="en-US" dirty="0"/>
+              <a:t>Client</a:t>
+            </a:r>
+          </a:p>
+          <a:p>
+            <a:pPr lvl="1"/>
+            <a:r>
+              <a:rPr lang="en-US" dirty="0">
+                <a:highlight>
+                  <a:srgbClr val="FFFF00"/>
+                </a:highlight>
+              </a:rPr>
+              <a:t>Testing (both client unit testing and E2E.</a:t>
+            </a:r>
+          </a:p>
+          <a:p>
+            <a:pPr lvl="1"/>
+            <a:r>
+              <a:rPr lang="en-US" dirty="0"/>
+              <a:t>Home (about) page.</a:t>
+            </a:r>
+          </a:p>
+          <a:p>
+            <a:r>
+              <a:rPr lang="en-US" dirty="0"/>
+              <a:t>Game (essentially untouched):</a:t>
+            </a:r>
+          </a:p>
+          <a:p>
+            <a:pPr lvl="1"/>
+            <a:r>
+              <a:rPr lang="en-US" dirty="0"/>
+              <a:t>Assets</a:t>
+            </a:r>
+          </a:p>
+          <a:p>
+            <a:pPr lvl="1"/>
+            <a:r>
+              <a:rPr lang="en-US" dirty="0"/>
+              <a:t>Rending</a:t>
+            </a:r>
+          </a:p>
+          <a:p>
+            <a:pPr lvl="1"/>
+            <a:r>
+              <a:rPr lang="en-US" dirty="0"/>
+              <a:t>Input</a:t>
+            </a:r>
+          </a:p>
+          <a:p>
+            <a:pPr lvl="1"/>
+            <a:r>
+              <a:rPr lang="en-US" dirty="0"/>
+              <a:t>Scripting actual gameplay</a:t>
+            </a:r>
+          </a:p>
+          <a:p>
+            <a:r>
+              <a:rPr lang="en-US" dirty="0"/>
+              <a:t>Deployment</a:t>
+            </a:r>
           </a:p>
         </p:txBody>
       </p:sp>
@@ -4742,12 +6135,8 @@
               <a:buNone/>
             </a:pPr>
             <a:r>
-              <a:rPr lang="en-US" dirty="0" err="1"/>
-              <a:t>Bintrong</a:t>
-            </a:r>
-            <a:r>
-              <a:rPr lang="en-US" dirty="0"/>
-              <a:t> game is a designed to be a free accessible game for students to study questions using competition. A key goal is make the solution freeware so anyone can host it for free. The plan is for the game application to provide options for generating card packs via LLM.</a:t>
+              <a:rPr lang="en-US" dirty="0"/>
+              <a:t>Bearcat/Binturong game is a designed to be a free accessible game for students to study questions using competition. A key goal is make the solution freeware so anyone can host it for free. The plan is for the game application to provide options for generating card packs via LLM.</a:t>
             </a:r>
             <a:endParaRPr lang="en-001" dirty="0"/>
           </a:p>
@@ -5233,7 +6622,7 @@
             <a:pPr lvl="1"/>
             <a:r>
               <a:rPr lang="en-US" dirty="0"/>
-              <a:t>Hosting costs</a:t>
+              <a:t>Hosting costs – primarily LLM inference</a:t>
             </a:r>
           </a:p>
           <a:p>
@@ -5359,45 +6748,81 @@
           <a:p>
             <a:r>
               <a:rPr lang="en-US" dirty="0"/>
-              <a:t>Implemented database tables for users</a:t>
-            </a:r>
-          </a:p>
-          <a:p>
-            <a:r>
-              <a:rPr lang="en-US" dirty="0"/>
-              <a:t>Midway through implemented file storage</a:t>
-            </a:r>
-          </a:p>
-          <a:p>
-            <a:r>
-              <a:rPr lang="en-US" dirty="0"/>
-              <a:t>Most infrastructure is setup for local:</a:t>
+              <a:t>Service hosting for development/debug</a:t>
+            </a:r>
+          </a:p>
+          <a:p>
+            <a:r>
+              <a:rPr lang="en-US" dirty="0"/>
+              <a:t>API:</a:t>
             </a:r>
           </a:p>
           <a:p>
             <a:pPr lvl="1"/>
             <a:r>
               <a:rPr lang="en-US" dirty="0"/>
-              <a:t>DB</a:t>
-            </a:r>
-          </a:p>
-          <a:p>
-            <a:pPr lvl="1"/>
-            <a:r>
-              <a:rPr lang="en-US" dirty="0"/>
-              <a:t>S3</a:t>
-            </a:r>
-          </a:p>
-          <a:p>
-            <a:pPr lvl="1"/>
-            <a:r>
-              <a:rPr lang="en-US" dirty="0"/>
-              <a:t>LLM – </a:t>
+              <a:t>Endpoint for inferencing </a:t>
             </a:r>
             <a:r>
               <a:rPr lang="en-US" dirty="0" err="1"/>
               <a:t>sglang</a:t>
             </a:r>
+            <a:r>
+              <a:rPr lang="en-US" dirty="0"/>
+              <a:t> service (in-progress).</a:t>
+            </a:r>
+          </a:p>
+          <a:p>
+            <a:pPr lvl="1"/>
+            <a:r>
+              <a:rPr lang="en-US" dirty="0"/>
+              <a:t>Endpoints for CRUD operations.</a:t>
+            </a:r>
+          </a:p>
+          <a:p>
+            <a:pPr lvl="1"/>
+            <a:r>
+              <a:rPr lang="en-US" dirty="0"/>
+              <a:t>Type definitions for </a:t>
+            </a:r>
+            <a:r>
+              <a:rPr lang="en-US" dirty="0" err="1"/>
+              <a:t>db</a:t>
+            </a:r>
+            <a:r>
+              <a:rPr lang="en-US" dirty="0"/>
+              <a:t>, ORM.</a:t>
+            </a:r>
+          </a:p>
+          <a:p>
+            <a:r>
+              <a:rPr lang="en-US" dirty="0"/>
+              <a:t>Client:</a:t>
+            </a:r>
+          </a:p>
+          <a:p>
+            <a:pPr lvl="1"/>
+            <a:r>
+              <a:rPr lang="en-US" dirty="0"/>
+              <a:t>Pages: Login, Files, Account</a:t>
+            </a:r>
+          </a:p>
+          <a:p>
+            <a:pPr lvl="1"/>
+            <a:r>
+              <a:rPr lang="en-US" dirty="0"/>
+              <a:t>Session</a:t>
+            </a:r>
+          </a:p>
+          <a:p>
+            <a:pPr lvl="1"/>
+            <a:endParaRPr lang="en-US" dirty="0"/>
+          </a:p>
+          <a:p>
+            <a:pPr lvl="1"/>
+            <a:endParaRPr lang="en-US" dirty="0"/>
+          </a:p>
+          <a:p>
             <a:endParaRPr lang="en-US" dirty="0"/>
           </a:p>
         </p:txBody>

</xml_diff>